<commit_message>
Move every demo link to https://webai.isainative.dev/ (deck text, links + QR, PDF, story, notes); built-in AI: no model names, neutral download progress, same options for availability()/create()
</commit_message>
<xml_diff>
--- a/deck/Ultimate-Guide-Browser-AI-2026.pptx
+++ b/deck/Ultimate-Guide-Browser-AI-2026.pptx
@@ -19753,7 +19753,7 @@
                 <a:latin typeface="Arial"/>
                 <a:hlinkClick r:id="rId4"/>
               </a:rPr>
-              <a:t>webai-playground.sites.tab.bot</a:t>
+              <a:t>webai.isainative.dev</a:t>
             </a:r>
           </a:p>
         </p:txBody>
@@ -26574,7 +26574,7 @@
                 <a:latin typeface="Arial"/>
                 <a:hlinkClick r:id="rId3"/>
               </a:rPr>
-              <a:t>webai-playground.sites.tab.bot</a:t>
+              <a:t>webai.isainative.dev</a:t>
             </a:r>
           </a:p>
         </p:txBody>
@@ -30022,7 +30022,7 @@
                 <a:latin typeface="Arial"/>
                 <a:hlinkClick r:id="rId4"/>
               </a:rPr>
-              <a:t>webai-playground.sites.tab.bot</a:t>
+              <a:t>webai.isainative.dev</a:t>
             </a:r>
           </a:p>
         </p:txBody>
@@ -37018,7 +37018,7 @@
                 <a:latin typeface="Arial"/>
                 <a:hlinkClick r:id="rId4"/>
               </a:rPr>
-              <a:t>webai-playground.sites.tab.bot</a:t>
+              <a:t>webai.isainative.dev</a:t>
             </a:r>
           </a:p>
         </p:txBody>

</xml_diff>

<commit_message>
Demo now at webai.isainative.dev; browser-neutral Prompt API text + assumptions audit (#3)
* Move every demo link to https://webai.isainative.dev/ (deck text, links + QR, PDF, story, notes); built-in AI: no model names, neutral download progress, same options for availability()/create()

* docs: ASSUMPTIONS-AUDIT.md (browser/vendor assumptions in the demo, what was fixed, sources); README link
</commit_message>
<xml_diff>
--- a/deck/Ultimate-Guide-Browser-AI-2026.pptx
+++ b/deck/Ultimate-Guide-Browser-AI-2026.pptx
@@ -19753,7 +19753,7 @@
                 <a:latin typeface="Arial"/>
                 <a:hlinkClick r:id="rId4"/>
               </a:rPr>
-              <a:t>webai-playground.sites.tab.bot</a:t>
+              <a:t>webai.isainative.dev</a:t>
             </a:r>
           </a:p>
         </p:txBody>
@@ -26574,7 +26574,7 @@
                 <a:latin typeface="Arial"/>
                 <a:hlinkClick r:id="rId3"/>
               </a:rPr>
-              <a:t>webai-playground.sites.tab.bot</a:t>
+              <a:t>webai.isainative.dev</a:t>
             </a:r>
           </a:p>
         </p:txBody>
@@ -30022,7 +30022,7 @@
                 <a:latin typeface="Arial"/>
                 <a:hlinkClick r:id="rId4"/>
               </a:rPr>
-              <a:t>webai-playground.sites.tab.bot</a:t>
+              <a:t>webai.isainative.dev</a:t>
             </a:r>
           </a:p>
         </p:txBody>
@@ -37018,7 +37018,7 @@
                 <a:latin typeface="Arial"/>
                 <a:hlinkClick r:id="rId4"/>
               </a:rPr>
-              <a:t>webai-playground.sites.tab.bot</a:t>
+              <a:t>webai.isainative.dev</a:t>
             </a:r>
           </a:p>
         </p:txBody>

</xml_diff>